<commit_message>
Record macOS Office and WPS native acceptance evidence
</commit_message>
<xml_diff>
--- a/docs/verification/microsoft-parity/ui-powerpoint-01/parity-ppt-ui.pptx
+++ b/docs/verification/microsoft-parity/ui-powerpoint-01/parity-ppt-ui.pptx
@@ -111,6 +111,11 @@
       </a:defRPr>
     </a:lvl9pPr>
   </p:defaultTextStyle>
+  <p:extLst>
+    <p:ext uri="{EFAFB233-063F-42B5-8137-9DF3F51BA10A}">
+      <p15:sldGuideLst xmlns:p15="http://schemas.microsoft.com/office/powerpoint/2012/main"/>
+    </p:ext>
+  </p:extLst>
 </p:presentation>
 </file>
 
@@ -196,7 +201,7 @@
           <a:p>
             <a:fld id="{BC207535-2A12-F246-A4FF-FB9E80D7047D}" type="datetimeFigureOut">
               <a:rPr kumimoji="1" lang="zh-CN" altLang="en-US" smtClean="0"/>
-              <a:t>2026/9/8</a:t>
+              <a:t>2026/9/9</a:t>
             </a:fld>
             <a:endParaRPr kumimoji="1" lang="zh-CN" altLang="en-US"/>
           </a:p>
@@ -1034,7 +1039,7 @@
           <a:p>
             <a:fld id="{0EB9B4E5-8DBA-DA47-98D8-9ECFF7749309}" type="datetimeFigureOut">
               <a:rPr kumimoji="1" lang="zh-CN" altLang="en-US" smtClean="0"/>
-              <a:t>2026/9/8</a:t>
+              <a:t>2026/9/9</a:t>
             </a:fld>
             <a:endParaRPr kumimoji="1" lang="zh-CN" altLang="en-US"/>
           </a:p>
@@ -1232,7 +1237,7 @@
           <a:p>
             <a:fld id="{0EB9B4E5-8DBA-DA47-98D8-9ECFF7749309}" type="datetimeFigureOut">
               <a:rPr kumimoji="1" lang="zh-CN" altLang="en-US" smtClean="0"/>
-              <a:t>2026/9/8</a:t>
+              <a:t>2026/9/9</a:t>
             </a:fld>
             <a:endParaRPr kumimoji="1" lang="zh-CN" altLang="en-US"/>
           </a:p>
@@ -1440,7 +1445,7 @@
           <a:p>
             <a:fld id="{0EB9B4E5-8DBA-DA47-98D8-9ECFF7749309}" type="datetimeFigureOut">
               <a:rPr kumimoji="1" lang="zh-CN" altLang="en-US" smtClean="0"/>
-              <a:t>2026/9/8</a:t>
+              <a:t>2026/9/9</a:t>
             </a:fld>
             <a:endParaRPr kumimoji="1" lang="zh-CN" altLang="en-US"/>
           </a:p>
@@ -1638,7 +1643,7 @@
           <a:p>
             <a:fld id="{0EB9B4E5-8DBA-DA47-98D8-9ECFF7749309}" type="datetimeFigureOut">
               <a:rPr kumimoji="1" lang="zh-CN" altLang="en-US" smtClean="0"/>
-              <a:t>2026/9/8</a:t>
+              <a:t>2026/9/9</a:t>
             </a:fld>
             <a:endParaRPr kumimoji="1" lang="zh-CN" altLang="en-US"/>
           </a:p>
@@ -1836,7 +1841,7 @@
           <a:p>
             <a:fld id="{0EB9B4E5-8DBA-DA47-98D8-9ECFF7749309}" type="datetimeFigureOut">
               <a:rPr kumimoji="1" lang="zh-CN" altLang="en-US" smtClean="0"/>
-              <a:t>2026/9/8</a:t>
+              <a:t>2026/9/9</a:t>
             </a:fld>
             <a:endParaRPr kumimoji="1" lang="zh-CN" altLang="en-US"/>
           </a:p>
@@ -2111,7 +2116,7 @@
           <a:p>
             <a:fld id="{0EB9B4E5-8DBA-DA47-98D8-9ECFF7749309}" type="datetimeFigureOut">
               <a:rPr kumimoji="1" lang="zh-CN" altLang="en-US" smtClean="0"/>
-              <a:t>2026/9/8</a:t>
+              <a:t>2026/9/9</a:t>
             </a:fld>
             <a:endParaRPr kumimoji="1" lang="zh-CN" altLang="en-US"/>
           </a:p>
@@ -2376,7 +2381,7 @@
           <a:p>
             <a:fld id="{0EB9B4E5-8DBA-DA47-98D8-9ECFF7749309}" type="datetimeFigureOut">
               <a:rPr kumimoji="1" lang="zh-CN" altLang="en-US" smtClean="0"/>
-              <a:t>2026/9/8</a:t>
+              <a:t>2026/9/9</a:t>
             </a:fld>
             <a:endParaRPr kumimoji="1" lang="zh-CN" altLang="en-US"/>
           </a:p>
@@ -2788,7 +2793,7 @@
           <a:p>
             <a:fld id="{0EB9B4E5-8DBA-DA47-98D8-9ECFF7749309}" type="datetimeFigureOut">
               <a:rPr kumimoji="1" lang="zh-CN" altLang="en-US" smtClean="0"/>
-              <a:t>2026/9/8</a:t>
+              <a:t>2026/9/9</a:t>
             </a:fld>
             <a:endParaRPr kumimoji="1" lang="zh-CN" altLang="en-US"/>
           </a:p>
@@ -2929,7 +2934,7 @@
           <a:p>
             <a:fld id="{0EB9B4E5-8DBA-DA47-98D8-9ECFF7749309}" type="datetimeFigureOut">
               <a:rPr kumimoji="1" lang="zh-CN" altLang="en-US" smtClean="0"/>
-              <a:t>2026/9/8</a:t>
+              <a:t>2026/9/9</a:t>
             </a:fld>
             <a:endParaRPr kumimoji="1" lang="zh-CN" altLang="en-US"/>
           </a:p>
@@ -3042,7 +3047,7 @@
           <a:p>
             <a:fld id="{0EB9B4E5-8DBA-DA47-98D8-9ECFF7749309}" type="datetimeFigureOut">
               <a:rPr kumimoji="1" lang="zh-CN" altLang="en-US" smtClean="0"/>
-              <a:t>2026/9/8</a:t>
+              <a:t>2026/9/9</a:t>
             </a:fld>
             <a:endParaRPr kumimoji="1" lang="zh-CN" altLang="en-US"/>
           </a:p>
@@ -3353,7 +3358,7 @@
           <a:p>
             <a:fld id="{0EB9B4E5-8DBA-DA47-98D8-9ECFF7749309}" type="datetimeFigureOut">
               <a:rPr kumimoji="1" lang="zh-CN" altLang="en-US" smtClean="0"/>
-              <a:t>2026/9/8</a:t>
+              <a:t>2026/9/9</a:t>
             </a:fld>
             <a:endParaRPr kumimoji="1" lang="zh-CN" altLang="en-US"/>
           </a:p>
@@ -3641,7 +3646,7 @@
           <a:p>
             <a:fld id="{0EB9B4E5-8DBA-DA47-98D8-9ECFF7749309}" type="datetimeFigureOut">
               <a:rPr kumimoji="1" lang="zh-CN" altLang="en-US" smtClean="0"/>
-              <a:t>2026/9/8</a:t>
+              <a:t>2026/9/9</a:t>
             </a:fld>
             <a:endParaRPr kumimoji="1" lang="zh-CN" altLang="en-US"/>
           </a:p>
@@ -3885,7 +3890,7 @@
           <a:p>
             <a:fld id="{0EB9B4E5-8DBA-DA47-98D8-9ECFF7749309}" type="datetimeFigureOut">
               <a:rPr kumimoji="1" lang="zh-CN" altLang="en-US" smtClean="0"/>
-              <a:t>2026/9/8</a:t>
+              <a:t>2026/9/9</a:t>
             </a:fld>
             <a:endParaRPr kumimoji="1" lang="zh-CN" altLang="en-US"/>
           </a:p>
@@ -4335,7 +4340,7 @@
               </a:rPr>
               <a:t>Semantic native title</a:t>
             </a:r>
-            <a:endParaRPr kumimoji="1" lang="zh-CN" altLang="en-US" sz="3600">
+            <a:endParaRPr kumimoji="1" lang="zh-CN" altLang="en-US" sz="3600" dirty="0">
               <a:solidFill>
                 <a:srgbClr val="003366"/>
               </a:solidFill>

</xml_diff>